<commit_message>
removing mistakes from PPT
</commit_message>
<xml_diff>
--- a/T9998_VIT-Chennai_Rahi_Sanxipt_Mehta_Review1.pptx
+++ b/T9998_VIT-Chennai_Rahi_Sanxipt_Mehta_Review1.pptx
@@ -3988,7 +3988,7 @@
         <p:spPr>
           <a:xfrm>
             <a:off x="180236" y="1659822"/>
-            <a:ext cx="11428184" cy="4431983"/>
+            <a:ext cx="11428184" cy="3600986"/>
           </a:xfrm>
           <a:prstGeom prst="rect">
             <a:avLst/>
@@ -4013,18 +4013,11 @@
               </a:rPr>
               <a:t>Agentic AI Assistant for Architectural Design and Project Coordination</a:t>
             </a:r>
-            <a:endParaRPr kumimoji="0" lang="en-US" sz="5400" b="1" i="0" u="none" strike="noStrike" kern="1200" cap="none" spc="0" normalizeH="0" baseline="0" noProof="0" dirty="0">
-              <a:ln>
-                <a:noFill/>
-              </a:ln>
+            <a:endParaRPr lang="en-US" sz="5400" b="1" dirty="0">
               <a:solidFill>
                 <a:prstClr val="white"/>
               </a:solidFill>
-              <a:effectLst/>
-              <a:uLnTx/>
-              <a:uFillTx/>
               <a:latin typeface="Frutiger 45 bold"/>
-              <a:ea typeface="+mn-ea"/>
               <a:cs typeface="Calibri" panose="020F0502020204030204" pitchFamily="34" charset="0"/>
             </a:endParaRPr>
           </a:p>
@@ -4074,11 +4067,6 @@
               </a:rPr>
               <a:t>Rahi Sanxipt Mehta</a:t>
             </a:r>
-          </a:p>
-          <a:p>
-            <a:pPr lvl="0" algn="ctr">
-              <a:defRPr/>
-            </a:pPr>
             <a:endParaRPr lang="en-US" sz="5400" b="1" dirty="0">
               <a:solidFill>
                 <a:prstClr val="white"/>
@@ -4896,6 +4884,7 @@
                 <a:solidFill>
                   <a:srgbClr val="5583D1"/>
                 </a:solidFill>
+                <a:latin typeface="Calibri (Body)"/>
               </a:rPr>
               <a:t>Develop a project-aware AI Assistant. </a:t>
             </a:r>
@@ -4911,6 +4900,7 @@
                 <a:solidFill>
                   <a:srgbClr val="5583D1"/>
                 </a:solidFill>
+                <a:latin typeface="Calibri (Body)"/>
               </a:rPr>
               <a:t>Enable autonomous tool-based task execution. </a:t>
             </a:r>
@@ -4926,6 +4916,7 @@
                 <a:solidFill>
                   <a:srgbClr val="5583D1"/>
                 </a:solidFill>
+                <a:latin typeface="Calibri (Body)"/>
               </a:rPr>
               <a:t>Provide AI-based architectural design reviews. </a:t>
             </a:r>
@@ -4941,6 +4932,7 @@
                 <a:solidFill>
                   <a:srgbClr val="5583D1"/>
                 </a:solidFill>
+                <a:latin typeface="Calibri (Body)"/>
               </a:rPr>
               <a:t>Automate architectural research and coordination.</a:t>
             </a:r>
@@ -4948,6 +4940,7 @@
               <a:solidFill>
                 <a:srgbClr val="5583D1"/>
               </a:solidFill>
+              <a:latin typeface="Calibri (Body)"/>
             </a:endParaRPr>
           </a:p>
         </p:txBody>
@@ -5412,12 +5405,22 @@
               </a:lnSpc>
             </a:pPr>
             <a:r>
-              <a:rPr lang="en-US" sz="2400" b="0" dirty="0">
+              <a:rPr lang="en-US" dirty="0">
                 <a:solidFill>
                   <a:srgbClr val="5583D1"/>
                 </a:solidFill>
+                <a:latin typeface="Calibri (Body)"/>
               </a:rPr>
-              <a:t>Application: A web-based platform for creating architectural projects and uploading relevant BIM/PDF documents. </a:t>
+              <a:t>Application:</a:t>
+            </a:r>
+            <a:r>
+              <a:rPr lang="en-US" b="0" dirty="0">
+                <a:solidFill>
+                  <a:srgbClr val="5583D1"/>
+                </a:solidFill>
+                <a:latin typeface="Calibri (Body)"/>
+              </a:rPr>
+              <a:t> A web-based platform for creating architectural projects and uploading relevant BIM/PDF documents. </a:t>
             </a:r>
           </a:p>
           <a:p>
@@ -5427,12 +5430,22 @@
               </a:lnSpc>
             </a:pPr>
             <a:r>
-              <a:rPr lang="en-US" sz="2400" b="0" dirty="0">
+              <a:rPr lang="en-US" dirty="0">
                 <a:solidFill>
                   <a:srgbClr val="5583D1"/>
                 </a:solidFill>
+                <a:latin typeface="Calibri (Body)"/>
               </a:rPr>
-              <a:t>Search &amp; Retrieval: Semantic search across architectural building codes. </a:t>
+              <a:t>Search &amp; Retrieval:</a:t>
+            </a:r>
+            <a:r>
+              <a:rPr lang="en-US" b="0" dirty="0">
+                <a:solidFill>
+                  <a:srgbClr val="5583D1"/>
+                </a:solidFill>
+                <a:latin typeface="Calibri (Body)"/>
+              </a:rPr>
+              <a:t> Semantic search across architectural building codes. </a:t>
             </a:r>
           </a:p>
           <a:p>
@@ -5442,12 +5455,22 @@
               </a:lnSpc>
             </a:pPr>
             <a:r>
-              <a:rPr lang="en-US" sz="2400" b="0" dirty="0">
+              <a:rPr lang="en-US" dirty="0">
                 <a:solidFill>
                   <a:srgbClr val="5583D1"/>
                 </a:solidFill>
+                <a:latin typeface="Calibri (Body)"/>
               </a:rPr>
-              <a:t>Automation: Automated compliance auditing of floor plan datasets . </a:t>
+              <a:t>Automation:</a:t>
+            </a:r>
+            <a:r>
+              <a:rPr lang="en-US" b="0" dirty="0">
+                <a:solidFill>
+                  <a:srgbClr val="5583D1"/>
+                </a:solidFill>
+                <a:latin typeface="Calibri (Body)"/>
+              </a:rPr>
+              <a:t> Automated compliance auditing of floor plan datasets . </a:t>
             </a:r>
           </a:p>
           <a:p>
@@ -5457,12 +5480,22 @@
               </a:lnSpc>
             </a:pPr>
             <a:r>
-              <a:rPr lang="en-US" sz="2400" b="0" dirty="0">
+              <a:rPr lang="en-US" dirty="0">
                 <a:solidFill>
                   <a:srgbClr val="5583D1"/>
                 </a:solidFill>
+                <a:latin typeface="Calibri (Body)"/>
               </a:rPr>
-              <a:t>Architecture: Integration of a multi-agent orchestration framework utilizing a local LLM for privacy and offline capability.</a:t>
+              <a:t>Architecture:</a:t>
+            </a:r>
+            <a:r>
+              <a:rPr lang="en-US" b="0" dirty="0">
+                <a:solidFill>
+                  <a:srgbClr val="5583D1"/>
+                </a:solidFill>
+                <a:latin typeface="Calibri (Body)"/>
+              </a:rPr>
+              <a:t> Integration of a multi-agent orchestration framework utilizing a local LLM for privacy and offline capability.</a:t>
             </a:r>
           </a:p>
         </p:txBody>
@@ -5927,13 +5960,22 @@
               </a:lnSpc>
             </a:pPr>
             <a:r>
-              <a:rPr lang="en-US" b="0" dirty="0">
+              <a:rPr lang="en-US" dirty="0">
                 <a:solidFill>
                   <a:srgbClr val="5583D1"/>
                 </a:solidFill>
                 <a:latin typeface="+mn-lt"/>
               </a:rPr>
-              <a:t>Multi-Agent Orchestration: Exploring state-machine based agent coordination (LangGraph) for deterministic execution of complex architectural tasks. </a:t>
+              <a:t>Multi-Agent Orchestration:</a:t>
+            </a:r>
+            <a:r>
+              <a:rPr lang="en-US" b="0" dirty="0">
+                <a:solidFill>
+                  <a:srgbClr val="5583D1"/>
+                </a:solidFill>
+                <a:latin typeface="+mn-lt"/>
+              </a:rPr>
+              <a:t> Exploring state-machine based agent coordination (LangGraph) for deterministic execution of complex architectural tasks. </a:t>
             </a:r>
           </a:p>
           <a:p>
@@ -5943,13 +5985,22 @@
               </a:lnSpc>
             </a:pPr>
             <a:r>
-              <a:rPr lang="en-US" b="0" dirty="0">
+              <a:rPr lang="en-US" dirty="0">
                 <a:solidFill>
                   <a:srgbClr val="5583D1"/>
                 </a:solidFill>
                 <a:latin typeface="+mn-lt"/>
               </a:rPr>
-              <a:t>RAG for Regulatory Documents: Utilizing Retrieval-Augmented Generation and Vector Databases (Chroma DB) to accurately parse and retrieve complex legal and dimensional requirements from building codes. </a:t>
+              <a:t>RAG for Regulatory Documents:</a:t>
+            </a:r>
+            <a:r>
+              <a:rPr lang="en-US" b="0" dirty="0">
+                <a:solidFill>
+                  <a:srgbClr val="5583D1"/>
+                </a:solidFill>
+                <a:latin typeface="+mn-lt"/>
+              </a:rPr>
+              <a:t> Utilizing Retrieval-Augmented Generation and Vector Databases (Chroma DB) to accurately parse and retrieve complex legal and dimensional requirements from building codes. </a:t>
             </a:r>
           </a:p>
           <a:p>
@@ -5959,13 +6010,22 @@
               </a:lnSpc>
             </a:pPr>
             <a:r>
-              <a:rPr lang="en-US" b="0" dirty="0">
+              <a:rPr lang="en-US" dirty="0">
                 <a:solidFill>
                   <a:srgbClr val="5583D1"/>
                 </a:solidFill>
                 <a:latin typeface="+mn-lt"/>
               </a:rPr>
-              <a:t>Architectural Data Processing: Techniques for extracting data from diverse architectural formats (PDFs, DOCX, IFC files) using PyMuPDF and ifcopenshell.</a:t>
+              <a:t>Architectural Data Processing:</a:t>
+            </a:r>
+            <a:r>
+              <a:rPr lang="en-US" b="0" dirty="0">
+                <a:solidFill>
+                  <a:srgbClr val="5583D1"/>
+                </a:solidFill>
+                <a:latin typeface="+mn-lt"/>
+              </a:rPr>
+              <a:t> Techniques for extracting data from diverse architectural formats (PDFs, DOCX, IFC files) using PyMuPDF and ifcopenshell.</a:t>
             </a:r>
             <a:endParaRPr lang="en-US" b="0" dirty="0">
               <a:solidFill>
@@ -6037,7 +6097,7 @@
                 <a:ea typeface="+mn-ea"/>
                 <a:cs typeface="+mn-cs"/>
               </a:rPr>
-              <a:t>Literature Review…. Calibri body -36</a:t>
+              <a:t>Literature Review</a:t>
             </a:r>
           </a:p>
         </p:txBody>
@@ -6716,13 +6776,22 @@
               </a:lnSpc>
             </a:pPr>
             <a:r>
-              <a:rPr lang="en-US" b="0" dirty="0">
+              <a:rPr lang="en-US" dirty="0">
                 <a:solidFill>
                   <a:srgbClr val="5583D1"/>
                 </a:solidFill>
                 <a:latin typeface="+mn-lt"/>
               </a:rPr>
-              <a:t>Tech Stack: LangGraph, Ollama (Llama 3.1), Streamlit (Frontend), </a:t>
+              <a:t>Tech Stack:</a:t>
+            </a:r>
+            <a:r>
+              <a:rPr lang="en-US" b="0" dirty="0">
+                <a:solidFill>
+                  <a:srgbClr val="5583D1"/>
+                </a:solidFill>
+                <a:latin typeface="+mn-lt"/>
+              </a:rPr>
+              <a:t> LangGraph, Ollama (Llama 3.1), Streamlit (Frontend), </a:t>
             </a:r>
             <a:r>
               <a:rPr lang="en-US" b="0" dirty="0" err="1">
@@ -6804,13 +6873,22 @@
               </a:lnSpc>
             </a:pPr>
             <a:r>
-              <a:rPr lang="en-US" b="0" dirty="0">
+              <a:rPr lang="en-US" dirty="0">
                 <a:solidFill>
                   <a:srgbClr val="5583D1"/>
                 </a:solidFill>
                 <a:latin typeface="+mn-lt"/>
               </a:rPr>
-              <a:t>Datasets: Custom dataset including public architecture documents, CubiCasa5k (floor plans), project scenarios, and agent evaluation datasets. </a:t>
+              <a:t>Datasets:</a:t>
+            </a:r>
+            <a:r>
+              <a:rPr lang="en-US" b="0" dirty="0">
+                <a:solidFill>
+                  <a:srgbClr val="5583D1"/>
+                </a:solidFill>
+                <a:latin typeface="+mn-lt"/>
+              </a:rPr>
+              <a:t> Custom dataset including public architecture documents, CubiCasa5k (floor plans), project scenarios, and agent evaluation datasets. </a:t>
             </a:r>
           </a:p>
           <a:p>
@@ -6820,13 +6898,22 @@
               </a:lnSpc>
             </a:pPr>
             <a:r>
-              <a:rPr lang="en-US" b="0" dirty="0">
+              <a:rPr lang="en-US" dirty="0">
                 <a:solidFill>
                   <a:srgbClr val="5583D1"/>
                 </a:solidFill>
                 <a:latin typeface="+mn-lt"/>
               </a:rPr>
-              <a:t>Expected Outcome: A unified platform delivering structured compliance reports, contextual recommendations, and automated code research.</a:t>
+              <a:t>Expected Outcome:</a:t>
+            </a:r>
+            <a:r>
+              <a:rPr lang="en-US" b="0" dirty="0">
+                <a:solidFill>
+                  <a:srgbClr val="5583D1"/>
+                </a:solidFill>
+                <a:latin typeface="+mn-lt"/>
+              </a:rPr>
+              <a:t> A unified platform delivering structured compliance reports, contextual recommendations, and automated code research.</a:t>
             </a:r>
             <a:endParaRPr lang="en-US" sz="2400" b="0" dirty="0">
               <a:solidFill>
@@ -6898,7 +6985,7 @@
                 <a:ea typeface="+mn-ea"/>
                 <a:cs typeface="+mn-cs"/>
               </a:rPr>
-              <a:t>Additional Information…. Calibri body -36</a:t>
+              <a:t>Additional Information</a:t>
             </a:r>
           </a:p>
         </p:txBody>
@@ -7249,7 +7336,16 @@
                 </a:solidFill>
                 <a:latin typeface="Calibri (Body)"/>
               </a:rPr>
-              <a:t>Module 1: Project Setup &amp; Knowledge Base Ingestion </a:t>
+              <a:t>Module 1:</a:t>
+            </a:r>
+            <a:r>
+              <a:rPr lang="en-US" b="0" dirty="0">
+                <a:solidFill>
+                  <a:srgbClr val="5583D1"/>
+                </a:solidFill>
+                <a:latin typeface="Calibri (Body)"/>
+              </a:rPr>
+              <a:t> Project Setup &amp; Knowledge Base Ingestion </a:t>
             </a:r>
           </a:p>
           <a:p>
@@ -7267,7 +7363,16 @@
                 </a:solidFill>
                 <a:latin typeface="Calibri (Body)"/>
               </a:rPr>
-              <a:t>Module 2: Multi-Agent Orchestration Engine (LangGraph) </a:t>
+              <a:t>Module 2:</a:t>
+            </a:r>
+            <a:r>
+              <a:rPr lang="en-US" b="0" dirty="0">
+                <a:solidFill>
+                  <a:srgbClr val="5583D1"/>
+                </a:solidFill>
+                <a:latin typeface="Calibri (Body)"/>
+              </a:rPr>
+              <a:t> Multi-Agent Orchestration Engine (LangGraph) </a:t>
             </a:r>
           </a:p>
           <a:p>
@@ -7285,7 +7390,16 @@
                 </a:solidFill>
                 <a:latin typeface="Calibri (Body)"/>
               </a:rPr>
-              <a:t>Module 3: Architectural Design Review Pipeline </a:t>
+              <a:t>Module 3:</a:t>
+            </a:r>
+            <a:r>
+              <a:rPr lang="en-US" b="0" dirty="0">
+                <a:solidFill>
+                  <a:srgbClr val="5583D1"/>
+                </a:solidFill>
+                <a:latin typeface="Calibri (Body)"/>
+              </a:rPr>
+              <a:t> Architectural Design Review Pipeline </a:t>
             </a:r>
           </a:p>
           <a:p>
@@ -7303,7 +7417,16 @@
                 </a:solidFill>
                 <a:latin typeface="Calibri (Body)"/>
               </a:rPr>
-              <a:t>Module 4: Agent Evaluation &amp; Performance Tracking</a:t>
+              <a:t>Module 4:</a:t>
+            </a:r>
+            <a:r>
+              <a:rPr lang="en-US" b="0" dirty="0">
+                <a:solidFill>
+                  <a:srgbClr val="5583D1"/>
+                </a:solidFill>
+                <a:latin typeface="Calibri (Body)"/>
+              </a:rPr>
+              <a:t> Agent Evaluation &amp; Performance Tracking</a:t>
             </a:r>
           </a:p>
         </p:txBody>

</xml_diff>

<commit_message>
feat: implement CI/CD pipeline, add architecture documentation, and integrate MLflow tracking server with MinIO storage
</commit_message>
<xml_diff>
--- a/T9998_VIT-Chennai_Rahi_Sanxipt_Mehta_Review1.pptx
+++ b/T9998_VIT-Chennai_Rahi_Sanxipt_Mehta_Review1.pptx
@@ -5,7 +5,7 @@
     <p:sldMasterId id="2147483660" r:id="rId1"/>
   </p:sldMasterIdLst>
   <p:notesMasterIdLst>
-    <p:notesMasterId r:id="rId11"/>
+    <p:notesMasterId r:id="rId12"/>
   </p:notesMasterIdLst>
   <p:sldIdLst>
     <p:sldId id="2147470489" r:id="rId2"/>
@@ -17,6 +17,7 @@
     <p:sldId id="2147470497" r:id="rId8"/>
     <p:sldId id="2147470491" r:id="rId9"/>
     <p:sldId id="2147470487" r:id="rId10"/>
+    <p:sldId id="261" r:id="rId11"/>
   </p:sldIdLst>
   <p:sldSz cx="12192000" cy="6858000"/>
   <p:notesSz cx="6858000" cy="9144000"/>
@@ -205,7 +206,7 @@
           <a:p>
             <a:fld id="{82314EA8-B22A-4773-A71C-4EFEFDE5A041}" type="datetimeFigureOut">
               <a:rPr lang="en-IN" smtClean="0"/>
-              <a:t>07-09-2026</a:t>
+              <a:t>11-09-2026</a:t>
             </a:fld>
             <a:endParaRPr lang="en-IN"/>
           </a:p>
@@ -4434,6 +4435,131 @@
 </p:sld>
 </file>
 
+<file path=ppt/slides/slide10.xml><?xml version="1.0" encoding="utf-8"?>
+<p:sld xmlns:a="http://schemas.openxmlformats.org/drawingml/2006/main" xmlns:r="http://schemas.openxmlformats.org/officeDocument/2006/relationships" xmlns:p="http://schemas.openxmlformats.org/presentationml/2006/main">
+  <p:cSld>
+    <p:spTree>
+      <p:nvGrpSpPr>
+        <p:cNvPr id="1" name=""/>
+        <p:cNvGrpSpPr/>
+        <p:nvPr/>
+      </p:nvGrpSpPr>
+      <p:grpSpPr>
+        <a:xfrm>
+          <a:off x="0" y="0"/>
+          <a:ext cx="0" cy="0"/>
+          <a:chOff x="0" y="0"/>
+          <a:chExt cx="0" cy="0"/>
+        </a:xfrm>
+      </p:grpSpPr>
+      <p:sp>
+        <p:nvSpPr>
+          <p:cNvPr id="2" name="Freeform 2"/>
+          <p:cNvSpPr/>
+          <p:nvPr/>
+        </p:nvSpPr>
+        <p:spPr>
+          <a:xfrm>
+            <a:off x="-613279" y="1863675"/>
+            <a:ext cx="13418557" cy="7441200"/>
+          </a:xfrm>
+          <a:custGeom>
+            <a:avLst/>
+            <a:gdLst/>
+            <a:ahLst/>
+            <a:cxnLst/>
+            <a:rect l="l" t="t" r="r" b="b"/>
+            <a:pathLst>
+              <a:path w="20127836" h="11161800">
+                <a:moveTo>
+                  <a:pt x="0" y="0"/>
+                </a:moveTo>
+                <a:lnTo>
+                  <a:pt x="20127836" y="0"/>
+                </a:lnTo>
+                <a:lnTo>
+                  <a:pt x="20127836" y="11161800"/>
+                </a:lnTo>
+                <a:lnTo>
+                  <a:pt x="0" y="11161800"/>
+                </a:lnTo>
+                <a:lnTo>
+                  <a:pt x="0" y="0"/>
+                </a:lnTo>
+                <a:close/>
+              </a:path>
+            </a:pathLst>
+          </a:custGeom>
+          <a:blipFill>
+            <a:blip>
+              <a:extLst>
+                <a:ext uri="{96DAC541-7B7A-43D3-8B79-37D633B846F1}">
+                  <asvg:svgBlip xmlns:asvg="http://schemas.microsoft.com/office/drawing/2016/SVG/main" r:embed="rId2"/>
+                </a:ext>
+              </a:extLst>
+            </a:blip>
+            <a:stretch>
+              <a:fillRect/>
+            </a:stretch>
+          </a:blipFill>
+        </p:spPr>
+        <p:txBody>
+          <a:bodyPr/>
+          <a:lstStyle/>
+          <a:p>
+            <a:endParaRPr lang="en-IN" sz="1200"/>
+          </a:p>
+        </p:txBody>
+      </p:sp>
+      <p:sp>
+        <p:nvSpPr>
+          <p:cNvPr id="3" name="TextBox 3"/>
+          <p:cNvSpPr txBox="1"/>
+          <p:nvPr/>
+        </p:nvSpPr>
+        <p:spPr>
+          <a:xfrm>
+            <a:off x="1992147" y="1761097"/>
+            <a:ext cx="8207706" cy="1752724"/>
+          </a:xfrm>
+          <a:prstGeom prst="rect">
+            <a:avLst/>
+          </a:prstGeom>
+        </p:spPr>
+        <p:txBody>
+          <a:bodyPr lIns="0" tIns="0" rIns="0" bIns="0" rtlCol="0" anchor="t">
+            <a:spAutoFit/>
+          </a:bodyPr>
+          <a:lstStyle/>
+          <a:p>
+            <a:pPr algn="ctr">
+              <a:lnSpc>
+                <a:spcPts val="14967"/>
+              </a:lnSpc>
+            </a:pPr>
+            <a:r>
+              <a:rPr lang="en-US" sz="10615" b="1" dirty="0">
+                <a:solidFill>
+                  <a:srgbClr val="1C1C1C"/>
+                </a:solidFill>
+                <a:latin typeface="Montserrat Bold"/>
+                <a:ea typeface="Montserrat Bold"/>
+                <a:cs typeface="Montserrat Bold"/>
+                <a:sym typeface="Montserrat Bold"/>
+              </a:rPr>
+              <a:t>Thank You</a:t>
+            </a:r>
+          </a:p>
+        </p:txBody>
+      </p:sp>
+    </p:spTree>
+  </p:cSld>
+  <p:clrMapOvr>
+    <a:masterClrMapping/>
+  </p:clrMapOvr>
+</p:sld>
+</file>
+
 <file path=ppt/slides/slide2.xml><?xml version="1.0" encoding="utf-8"?>
 <p:sld xmlns:a="http://schemas.openxmlformats.org/drawingml/2006/main" xmlns:r="http://schemas.openxmlformats.org/officeDocument/2006/relationships" xmlns:p="http://schemas.openxmlformats.org/presentationml/2006/main">
   <p:cSld>
@@ -5930,113 +6056,6 @@
       </p:grpSpPr>
       <p:sp>
         <p:nvSpPr>
-          <p:cNvPr id="2" name="Text Placeholder 1">
-            <a:extLst>
-              <a:ext uri="{FF2B5EF4-FFF2-40B4-BE49-F238E27FC236}">
-                <a16:creationId xmlns:a16="http://schemas.microsoft.com/office/drawing/2014/main" id="{DB433ECB-8EAD-0AB5-1D66-62BCF658AA2C}"/>
-              </a:ext>
-            </a:extLst>
-          </p:cNvPr>
-          <p:cNvSpPr>
-            <a:spLocks noGrp="1"/>
-          </p:cNvSpPr>
-          <p:nvPr>
-            <p:ph type="body" sz="quarter" idx="13"/>
-          </p:nvPr>
-        </p:nvSpPr>
-        <p:spPr>
-          <a:xfrm>
-            <a:off x="255996" y="1271219"/>
-            <a:ext cx="10624338" cy="4677296"/>
-          </a:xfrm>
-        </p:spPr>
-        <p:txBody>
-          <a:bodyPr/>
-          <a:lstStyle/>
-          <a:p>
-            <a:pPr>
-              <a:lnSpc>
-                <a:spcPct val="100000"/>
-              </a:lnSpc>
-            </a:pPr>
-            <a:r>
-              <a:rPr lang="en-US" dirty="0">
-                <a:solidFill>
-                  <a:srgbClr val="5583D1"/>
-                </a:solidFill>
-                <a:latin typeface="+mn-lt"/>
-              </a:rPr>
-              <a:t>Multi-Agent Orchestration:</a:t>
-            </a:r>
-            <a:r>
-              <a:rPr lang="en-US" b="0" dirty="0">
-                <a:solidFill>
-                  <a:srgbClr val="5583D1"/>
-                </a:solidFill>
-                <a:latin typeface="+mn-lt"/>
-              </a:rPr>
-              <a:t> Exploring state-machine based agent coordination (LangGraph) for deterministic execution of complex architectural tasks. </a:t>
-            </a:r>
-          </a:p>
-          <a:p>
-            <a:pPr>
-              <a:lnSpc>
-                <a:spcPct val="100000"/>
-              </a:lnSpc>
-            </a:pPr>
-            <a:r>
-              <a:rPr lang="en-US" dirty="0">
-                <a:solidFill>
-                  <a:srgbClr val="5583D1"/>
-                </a:solidFill>
-                <a:latin typeface="+mn-lt"/>
-              </a:rPr>
-              <a:t>RAG for Regulatory Documents:</a:t>
-            </a:r>
-            <a:r>
-              <a:rPr lang="en-US" b="0" dirty="0">
-                <a:solidFill>
-                  <a:srgbClr val="5583D1"/>
-                </a:solidFill>
-                <a:latin typeface="+mn-lt"/>
-              </a:rPr>
-              <a:t> Utilizing Retrieval-Augmented Generation and Vector Databases (Chroma DB) to accurately parse and retrieve complex legal and dimensional requirements from building codes. </a:t>
-            </a:r>
-          </a:p>
-          <a:p>
-            <a:pPr>
-              <a:lnSpc>
-                <a:spcPct val="100000"/>
-              </a:lnSpc>
-            </a:pPr>
-            <a:r>
-              <a:rPr lang="en-US" dirty="0">
-                <a:solidFill>
-                  <a:srgbClr val="5583D1"/>
-                </a:solidFill>
-                <a:latin typeface="+mn-lt"/>
-              </a:rPr>
-              <a:t>Architectural Data Processing:</a:t>
-            </a:r>
-            <a:r>
-              <a:rPr lang="en-US" b="0" dirty="0">
-                <a:solidFill>
-                  <a:srgbClr val="5583D1"/>
-                </a:solidFill>
-                <a:latin typeface="+mn-lt"/>
-              </a:rPr>
-              <a:t> Techniques for extracting data from diverse architectural formats (PDFs, DOCX, IFC files) using PyMuPDF and ifcopenshell.</a:t>
-            </a:r>
-            <a:endParaRPr lang="en-US" b="0" dirty="0">
-              <a:solidFill>
-                <a:srgbClr val="5583D1"/>
-              </a:solidFill>
-            </a:endParaRPr>
-          </a:p>
-        </p:txBody>
-      </p:sp>
-      <p:sp>
-        <p:nvSpPr>
           <p:cNvPr id="3" name="TextBox 2">
             <a:extLst>
               <a:ext uri="{FF2B5EF4-FFF2-40B4-BE49-F238E27FC236}">
@@ -6186,10 +6205,507 @@
           </a:p>
         </p:txBody>
       </p:sp>
+      <p:graphicFrame>
+        <p:nvGraphicFramePr>
+          <p:cNvPr id="6" name="Table 5">
+            <a:extLst>
+              <a:ext uri="{FF2B5EF4-FFF2-40B4-BE49-F238E27FC236}">
+                <a16:creationId xmlns:a16="http://schemas.microsoft.com/office/drawing/2014/main" id="{F7EC711B-F6F4-3721-E638-DAC2530007F9}"/>
+              </a:ext>
+            </a:extLst>
+          </p:cNvPr>
+          <p:cNvGraphicFramePr>
+            <a:graphicFrameLocks noGrp="1"/>
+          </p:cNvGraphicFramePr>
+          <p:nvPr>
+            <p:extLst>
+              <p:ext uri="{D42A27DB-BD31-4B8C-83A1-F6EECF244321}">
+                <p14:modId xmlns:p14="http://schemas.microsoft.com/office/powerpoint/2010/main" val="2338330744"/>
+              </p:ext>
+            </p:extLst>
+          </p:nvPr>
+        </p:nvGraphicFramePr>
+        <p:xfrm>
+          <a:off x="221274" y="1325538"/>
+          <a:ext cx="11803578" cy="4375889"/>
+        </p:xfrm>
+        <a:graphic>
+          <a:graphicData uri="http://schemas.openxmlformats.org/drawingml/2006/table">
+            <a:tbl>
+              <a:tblPr firstRow="1" bandRow="1">
+                <a:tableStyleId>{5C22544A-7EE6-4342-B048-85BDC9FD1C3A}</a:tableStyleId>
+              </a:tblPr>
+              <a:tblGrid>
+                <a:gridCol w="5901789">
+                  <a:extLst>
+                    <a:ext uri="{9D8B030D-6E8A-4147-A177-3AD203B41FA5}">
+                      <a16:colId xmlns:a16="http://schemas.microsoft.com/office/drawing/2014/main" val="3921002726"/>
+                    </a:ext>
+                  </a:extLst>
+                </a:gridCol>
+                <a:gridCol w="5901789">
+                  <a:extLst>
+                    <a:ext uri="{9D8B030D-6E8A-4147-A177-3AD203B41FA5}">
+                      <a16:colId xmlns:a16="http://schemas.microsoft.com/office/drawing/2014/main" val="2992007525"/>
+                    </a:ext>
+                  </a:extLst>
+                </a:gridCol>
+              </a:tblGrid>
+              <a:tr h="809729">
+                <a:tc>
+                  <a:txBody>
+                    <a:bodyPr/>
+                    <a:lstStyle/>
+                    <a:p>
+                      <a:pPr algn="ctr"/>
+                      <a:r>
+                        <a:rPr lang="en-IN" sz="3600" b="1" i="0" kern="1200" dirty="0">
+                          <a:solidFill>
+                            <a:schemeClr val="lt1"/>
+                          </a:solidFill>
+                          <a:effectLst/>
+                          <a:latin typeface="+mn-lt"/>
+                          <a:ea typeface="+mn-ea"/>
+                          <a:cs typeface="+mn-cs"/>
+                        </a:rPr>
+                        <a:t>Paper </a:t>
+                      </a:r>
+                      <a:endParaRPr lang="en-IN" i="0" dirty="0"/>
+                    </a:p>
+                  </a:txBody>
+                  <a:tcPr/>
+                </a:tc>
+                <a:tc>
+                  <a:txBody>
+                    <a:bodyPr/>
+                    <a:lstStyle/>
+                    <a:p>
+                      <a:pPr algn="ctr"/>
+                      <a:r>
+                        <a:rPr lang="en-IN" sz="3600" b="1" i="0" kern="1200" dirty="0">
+                          <a:solidFill>
+                            <a:schemeClr val="lt1"/>
+                          </a:solidFill>
+                          <a:effectLst/>
+                          <a:latin typeface="+mn-lt"/>
+                          <a:ea typeface="+mn-ea"/>
+                          <a:cs typeface="+mn-cs"/>
+                        </a:rPr>
+                        <a:t>Summary</a:t>
+                      </a:r>
+                      <a:endParaRPr lang="en-IN" i="0" dirty="0"/>
+                    </a:p>
+                  </a:txBody>
+                  <a:tcPr/>
+                </a:tc>
+                <a:extLst>
+                  <a:ext uri="{0D108BD9-81ED-4DB2-BD59-A6C34878D82A}">
+                    <a16:rowId xmlns:a16="http://schemas.microsoft.com/office/drawing/2014/main" val="3622561219"/>
+                  </a:ext>
+                </a:extLst>
+              </a:tr>
+              <a:tr h="1042672">
+                <a:tc>
+                  <a:txBody>
+                    <a:bodyPr/>
+                    <a:lstStyle/>
+                    <a:p>
+                      <a:r>
+                        <a:rPr lang="en-GB" sz="1800" i="0" dirty="0"/>
+                        <a:t>"An Agentic AI System for Roof Design Compliance Using Asynchronous Multi-Agent Architectures" (MDPI, 2026)</a:t>
+                      </a:r>
+                      <a:endParaRPr lang="en-IN" sz="1800" i="0" dirty="0"/>
+                    </a:p>
+                  </a:txBody>
+                  <a:tcPr/>
+                </a:tc>
+                <a:tc>
+                  <a:txBody>
+                    <a:bodyPr/>
+                    <a:lstStyle/>
+                    <a:p>
+                      <a:r>
+                        <a:rPr lang="en-GB" sz="1800" i="0" dirty="0"/>
+                        <a:t>Demonstrates the effectiveness of orchestrating specialized LLM agents with Retrieval-Augmented Generation (RAG) to autonomously verify complex building codes and structural compliance, significantly reducing manual review times.</a:t>
+                      </a:r>
+                      <a:endParaRPr lang="en-IN" sz="1800" i="0" dirty="0"/>
+                    </a:p>
+                  </a:txBody>
+                  <a:tcPr/>
+                </a:tc>
+                <a:extLst>
+                  <a:ext uri="{0D108BD9-81ED-4DB2-BD59-A6C34878D82A}">
+                    <a16:rowId xmlns:a16="http://schemas.microsoft.com/office/drawing/2014/main" val="3943249158"/>
+                  </a:ext>
+                </a:extLst>
+              </a:tr>
+              <a:tr h="1042672">
+                <a:tc>
+                  <a:txBody>
+                    <a:bodyPr/>
+                    <a:lstStyle/>
+                    <a:p>
+                      <a:r>
+                        <a:rPr lang="en-IN" sz="1800" b="0" i="0" kern="1200" dirty="0">
+                          <a:solidFill>
+                            <a:schemeClr val="dk1"/>
+                          </a:solidFill>
+                          <a:effectLst/>
+                          <a:latin typeface="+mn-lt"/>
+                          <a:ea typeface="+mn-ea"/>
+                          <a:cs typeface="+mn-cs"/>
+                        </a:rPr>
+                        <a:t>"Conversational, Agentic AI-Enhanced Architectural Design Process" (2025)</a:t>
+                      </a:r>
+                      <a:endParaRPr lang="en-IN" sz="1800" i="0" dirty="0"/>
+                    </a:p>
+                  </a:txBody>
+                  <a:tcPr/>
+                </a:tc>
+                <a:tc>
+                  <a:txBody>
+                    <a:bodyPr/>
+                    <a:lstStyle/>
+                    <a:p>
+                      <a:r>
+                        <a:rPr lang="en-IN" sz="1800" b="0" i="0" kern="1200" dirty="0">
+                          <a:solidFill>
+                            <a:schemeClr val="dk1"/>
+                          </a:solidFill>
+                          <a:effectLst/>
+                          <a:latin typeface="+mn-lt"/>
+                          <a:ea typeface="+mn-ea"/>
+                          <a:cs typeface="+mn-cs"/>
+                        </a:rPr>
+                        <a:t> Explores the integration of multi-agent workflows as collaborative "Design Partners," allowing architects to rapidly iterate on building layouts and BIM integration through natural language prompts.</a:t>
+                      </a:r>
+                      <a:endParaRPr lang="en-IN" sz="1800" i="0" dirty="0"/>
+                    </a:p>
+                  </a:txBody>
+                  <a:tcPr/>
+                </a:tc>
+                <a:extLst>
+                  <a:ext uri="{0D108BD9-81ED-4DB2-BD59-A6C34878D82A}">
+                    <a16:rowId xmlns:a16="http://schemas.microsoft.com/office/drawing/2014/main" val="1833608361"/>
+                  </a:ext>
+                </a:extLst>
+              </a:tr>
+              <a:tr h="1042672">
+                <a:tc>
+                  <a:txBody>
+                    <a:bodyPr/>
+                    <a:lstStyle/>
+                    <a:p>
+                      <a:r>
+                        <a:rPr lang="en-IN" sz="1800" b="0" i="0" kern="1200" dirty="0">
+                          <a:solidFill>
+                            <a:schemeClr val="dk1"/>
+                          </a:solidFill>
+                          <a:effectLst/>
+                          <a:latin typeface="+mn-lt"/>
+                          <a:ea typeface="+mn-ea"/>
+                          <a:cs typeface="+mn-cs"/>
+                        </a:rPr>
+                        <a:t>"LLM-Based Multi-Agent Orchestration: A Survey of Frameworks and Communication Protocols" (MDPI, 2026)</a:t>
+                      </a:r>
+                      <a:endParaRPr lang="en-IN" sz="1800" i="0" dirty="0"/>
+                    </a:p>
+                  </a:txBody>
+                  <a:tcPr/>
+                </a:tc>
+                <a:tc>
+                  <a:txBody>
+                    <a:bodyPr/>
+                    <a:lstStyle/>
+                    <a:p>
+                      <a:r>
+                        <a:rPr lang="en-GB" sz="1800" i="0" dirty="0"/>
+                        <a:t>Highlights the necessity of state-machine frameworks (such as LangGraph) to maintain deterministic execution, strict audit trails, and data privacy in complex, enterprise-level multi-agent systems.</a:t>
+                      </a:r>
+                      <a:endParaRPr lang="en-IN" sz="1800" i="0" dirty="0"/>
+                    </a:p>
+                  </a:txBody>
+                  <a:tcPr/>
+                </a:tc>
+                <a:extLst>
+                  <a:ext uri="{0D108BD9-81ED-4DB2-BD59-A6C34878D82A}">
+                    <a16:rowId xmlns:a16="http://schemas.microsoft.com/office/drawing/2014/main" val="3304057240"/>
+                  </a:ext>
+                </a:extLst>
+              </a:tr>
+            </a:tbl>
+          </a:graphicData>
+        </a:graphic>
+      </p:graphicFrame>
     </p:spTree>
     <p:extLst>
       <p:ext uri="{BB962C8B-B14F-4D97-AF65-F5344CB8AC3E}">
         <p14:creationId xmlns:p14="http://schemas.microsoft.com/office/powerpoint/2010/main" val="860765087"/>
+      </p:ext>
+    </p:extLst>
+  </p:cSld>
+  <p:clrMapOvr>
+    <a:masterClrMapping/>
+  </p:clrMapOvr>
+  <mc:AlternateContent xmlns:mc="http://schemas.openxmlformats.org/markup-compatibility/2006" xmlns:p14="http://schemas.microsoft.com/office/powerpoint/2010/main">
+    <mc:Choice Requires="p14">
+      <p:transition spd="med" p14:dur="700">
+        <p:fade/>
+      </p:transition>
+    </mc:Choice>
+    <mc:Fallback xmlns="">
+      <p:transition spd="med">
+        <p:fade/>
+      </p:transition>
+    </mc:Fallback>
+  </mc:AlternateContent>
+</p:sld>
+</file>
+
+<file path=ppt/slides/slide6.xml><?xml version="1.0" encoding="utf-8"?>
+<p:sld xmlns:a="http://schemas.openxmlformats.org/drawingml/2006/main" xmlns:r="http://schemas.openxmlformats.org/officeDocument/2006/relationships" xmlns:p="http://schemas.openxmlformats.org/presentationml/2006/main">
+  <p:cSld>
+    <p:spTree>
+      <p:nvGrpSpPr>
+        <p:cNvPr id="1" name="">
+          <a:extLst>
+            <a:ext uri="{FF2B5EF4-FFF2-40B4-BE49-F238E27FC236}">
+              <a16:creationId xmlns:a16="http://schemas.microsoft.com/office/drawing/2014/main" id="{B5253C69-472F-A80F-ECBC-553E043DB9CF}"/>
+            </a:ext>
+          </a:extLst>
+        </p:cNvPr>
+        <p:cNvGrpSpPr/>
+        <p:nvPr/>
+      </p:nvGrpSpPr>
+      <p:grpSpPr>
+        <a:xfrm>
+          <a:off x="0" y="0"/>
+          <a:ext cx="0" cy="0"/>
+          <a:chOff x="0" y="0"/>
+          <a:chExt cx="0" cy="0"/>
+        </a:xfrm>
+      </p:grpSpPr>
+      <p:sp>
+        <p:nvSpPr>
+          <p:cNvPr id="2" name="Text Placeholder 1">
+            <a:extLst>
+              <a:ext uri="{FF2B5EF4-FFF2-40B4-BE49-F238E27FC236}">
+                <a16:creationId xmlns:a16="http://schemas.microsoft.com/office/drawing/2014/main" id="{A364AF3A-1BAA-BB19-865F-8604C4E3B859}"/>
+              </a:ext>
+            </a:extLst>
+          </p:cNvPr>
+          <p:cNvSpPr>
+            <a:spLocks noGrp="1"/>
+          </p:cNvSpPr>
+          <p:nvPr>
+            <p:ph type="body" sz="quarter" idx="13"/>
+          </p:nvPr>
+        </p:nvSpPr>
+        <p:spPr>
+          <a:xfrm>
+            <a:off x="255995" y="1271219"/>
+            <a:ext cx="11650870" cy="4142989"/>
+          </a:xfrm>
+        </p:spPr>
+        <p:txBody>
+          <a:bodyPr/>
+          <a:lstStyle/>
+          <a:p>
+            <a:pPr marL="0" indent="0">
+              <a:lnSpc>
+                <a:spcPct val="100000"/>
+              </a:lnSpc>
+              <a:buNone/>
+            </a:pPr>
+            <a:r>
+              <a:rPr lang="en-GB" b="0" dirty="0">
+                <a:solidFill>
+                  <a:srgbClr val="5583D1"/>
+                </a:solidFill>
+                <a:latin typeface="+mn-lt"/>
+              </a:rPr>
+              <a:t>Recent literature (2024–2026) highlights a shift from simple chatbots to autonomous agentic systems. Studies confirm that standalone LLMs are insufficient for architecture due to hallucinations. However, integrating Retrieval-Augmented Generation (RAG) effectively grounds the AI in structured building codes, ensuring accurate compliance audits.</a:t>
+            </a:r>
+          </a:p>
+          <a:p>
+            <a:pPr marL="0" indent="0">
+              <a:lnSpc>
+                <a:spcPct val="100000"/>
+              </a:lnSpc>
+              <a:buNone/>
+            </a:pPr>
+            <a:r>
+              <a:rPr lang="en-GB" b="0" dirty="0">
+                <a:solidFill>
+                  <a:srgbClr val="5583D1"/>
+                </a:solidFill>
+                <a:latin typeface="+mn-lt"/>
+              </a:rPr>
+              <a:t>Furthermore, managing complex architectural workflows requires deterministic execution. Research strongly supports "Orchestrator-Worker" frameworks like LangGraph to route tasks to specialized agents reliably. Finally, literature emphasizes the critical need for data privacy with proprietary BIM files, validating our use of local execution models like Ollama.</a:t>
+            </a:r>
+            <a:endParaRPr lang="en-US" b="0" dirty="0">
+              <a:solidFill>
+                <a:srgbClr val="5583D1"/>
+              </a:solidFill>
+            </a:endParaRPr>
+          </a:p>
+        </p:txBody>
+      </p:sp>
+      <p:sp>
+        <p:nvSpPr>
+          <p:cNvPr id="3" name="TextBox 2">
+            <a:extLst>
+              <a:ext uri="{FF2B5EF4-FFF2-40B4-BE49-F238E27FC236}">
+                <a16:creationId xmlns:a16="http://schemas.microsoft.com/office/drawing/2014/main" id="{C7C2521A-B8A4-7818-FEB4-0309182DBECF}"/>
+              </a:ext>
+            </a:extLst>
+          </p:cNvPr>
+          <p:cNvSpPr txBox="1"/>
+          <p:nvPr/>
+        </p:nvSpPr>
+        <p:spPr>
+          <a:xfrm>
+            <a:off x="255996" y="502545"/>
+            <a:ext cx="10624338" cy="646331"/>
+          </a:xfrm>
+          <a:prstGeom prst="rect">
+            <a:avLst/>
+          </a:prstGeom>
+          <a:noFill/>
+        </p:spPr>
+        <p:txBody>
+          <a:bodyPr wrap="square" rtlCol="0">
+            <a:spAutoFit/>
+          </a:bodyPr>
+          <a:lstStyle/>
+          <a:p>
+            <a:pPr marL="0" marR="0" lvl="0" indent="0" algn="l" defTabSz="914400" rtl="0" eaLnBrk="1" fontAlgn="auto" latinLnBrk="0" hangingPunct="1">
+              <a:lnSpc>
+                <a:spcPct val="100000"/>
+              </a:lnSpc>
+              <a:spcBef>
+                <a:spcPts val="0"/>
+              </a:spcBef>
+              <a:spcAft>
+                <a:spcPts val="0"/>
+              </a:spcAft>
+              <a:buClrTx/>
+              <a:buSzTx/>
+              <a:buFontTx/>
+              <a:buNone/>
+              <a:tabLst/>
+              <a:defRPr/>
+            </a:pPr>
+            <a:r>
+              <a:rPr kumimoji="0" lang="en-US" sz="3600" b="1" i="0" u="none" strike="noStrike" kern="1200" cap="none" spc="0" normalizeH="0" baseline="0" noProof="0" dirty="0">
+                <a:ln>
+                  <a:noFill/>
+                </a:ln>
+                <a:solidFill>
+                  <a:srgbClr val="5B9BD5">
+                    <a:lumMod val="50000"/>
+                  </a:srgbClr>
+                </a:solidFill>
+                <a:effectLst/>
+                <a:uLnTx/>
+                <a:uFillTx/>
+                <a:latin typeface="Calibri" panose="020F0502020204030204"/>
+                <a:ea typeface="+mn-ea"/>
+                <a:cs typeface="+mn-cs"/>
+              </a:rPr>
+              <a:t>Summary of Literature</a:t>
+            </a:r>
+          </a:p>
+        </p:txBody>
+      </p:sp>
+      <p:cxnSp>
+        <p:nvCxnSpPr>
+          <p:cNvPr id="5" name="Straight Connector 4">
+            <a:extLst>
+              <a:ext uri="{FF2B5EF4-FFF2-40B4-BE49-F238E27FC236}">
+                <a16:creationId xmlns:a16="http://schemas.microsoft.com/office/drawing/2014/main" id="{76871527-EAED-D60A-DB4D-12A2CE4201DE}"/>
+              </a:ext>
+            </a:extLst>
+          </p:cNvPr>
+          <p:cNvCxnSpPr>
+            <a:cxnSpLocks/>
+          </p:cNvCxnSpPr>
+          <p:nvPr/>
+        </p:nvCxnSpPr>
+        <p:spPr>
+          <a:xfrm>
+            <a:off x="221274" y="1191756"/>
+            <a:ext cx="7305799" cy="0"/>
+          </a:xfrm>
+          <a:prstGeom prst="line">
+            <a:avLst/>
+          </a:prstGeom>
+          <a:ln w="28575">
+            <a:solidFill>
+              <a:schemeClr val="accent6"/>
+            </a:solidFill>
+          </a:ln>
+        </p:spPr>
+        <p:style>
+          <a:lnRef idx="1">
+            <a:schemeClr val="accent1"/>
+          </a:lnRef>
+          <a:fillRef idx="0">
+            <a:schemeClr val="accent1"/>
+          </a:fillRef>
+          <a:effectRef idx="0">
+            <a:schemeClr val="accent1"/>
+          </a:effectRef>
+          <a:fontRef idx="minor">
+            <a:schemeClr val="tx1"/>
+          </a:fontRef>
+        </p:style>
+      </p:cxnSp>
+      <p:sp>
+        <p:nvSpPr>
+          <p:cNvPr id="4" name="TextBox 3">
+            <a:extLst>
+              <a:ext uri="{FF2B5EF4-FFF2-40B4-BE49-F238E27FC236}">
+                <a16:creationId xmlns:a16="http://schemas.microsoft.com/office/drawing/2014/main" id="{8EADF6DB-6CFE-DDC5-997C-E84EE1A9470D}"/>
+              </a:ext>
+            </a:extLst>
+          </p:cNvPr>
+          <p:cNvSpPr txBox="1"/>
+          <p:nvPr/>
+        </p:nvSpPr>
+        <p:spPr>
+          <a:xfrm>
+            <a:off x="6093893" y="57036"/>
+            <a:ext cx="6098107" cy="646331"/>
+          </a:xfrm>
+          <a:prstGeom prst="rect">
+            <a:avLst/>
+          </a:prstGeom>
+          <a:noFill/>
+        </p:spPr>
+        <p:txBody>
+          <a:bodyPr wrap="square" rtlCol="0">
+            <a:spAutoFit/>
+          </a:bodyPr>
+          <a:lstStyle/>
+          <a:p>
+            <a:pPr algn="r"/>
+            <a:r>
+              <a:rPr lang="en-GB" b="1" i="1" dirty="0">
+                <a:solidFill>
+                  <a:srgbClr val="FFFFFF"/>
+                </a:solidFill>
+              </a:rPr>
+              <a:t>Agentic AI Assistant for Architectural Design and Project Coordination</a:t>
+            </a:r>
+            <a:endParaRPr lang="en-US" dirty="0"/>
+          </a:p>
+        </p:txBody>
+      </p:sp>
+    </p:spTree>
+    <p:extLst>
+      <p:ext uri="{BB962C8B-B14F-4D97-AF65-F5344CB8AC3E}">
+        <p14:creationId xmlns:p14="http://schemas.microsoft.com/office/powerpoint/2010/main" val="4084703370"/>
       </p:ext>
     </p:extLst>
   </p:cSld>
@@ -6294,385 +6810,6 @@
                                           <p:spTgt spid="2">
                                             <p:txEl>
                                               <p:pRg st="1" end="1"/>
-                                            </p:txEl>
-                                          </p:spTgt>
-                                        </p:tgtEl>
-                                        <p:attrNameLst>
-                                          <p:attrName>style.visibility</p:attrName>
-                                        </p:attrNameLst>
-                                      </p:cBhvr>
-                                      <p:to>
-                                        <p:strVal val="visible"/>
-                                      </p:to>
-                                    </p:set>
-                                  </p:childTnLst>
-                                </p:cTn>
-                              </p:par>
-                            </p:childTnLst>
-                          </p:cTn>
-                        </p:par>
-                      </p:childTnLst>
-                    </p:cTn>
-                  </p:par>
-                  <p:par>
-                    <p:cTn id="11" fill="hold">
-                      <p:stCondLst>
-                        <p:cond delay="indefinite"/>
-                      </p:stCondLst>
-                      <p:childTnLst>
-                        <p:par>
-                          <p:cTn id="12" fill="hold">
-                            <p:stCondLst>
-                              <p:cond delay="0"/>
-                            </p:stCondLst>
-                            <p:childTnLst>
-                              <p:par>
-                                <p:cTn id="13" presetID="1" presetClass="entr" presetSubtype="0" fill="hold" grpId="0" nodeType="clickEffect">
-                                  <p:stCondLst>
-                                    <p:cond delay="0"/>
-                                  </p:stCondLst>
-                                  <p:childTnLst>
-                                    <p:set>
-                                      <p:cBhvr>
-                                        <p:cTn id="14" dur="1" fill="hold">
-                                          <p:stCondLst>
-                                            <p:cond delay="0"/>
-                                          </p:stCondLst>
-                                        </p:cTn>
-                                        <p:tgtEl>
-                                          <p:spTgt spid="2">
-                                            <p:txEl>
-                                              <p:pRg st="2" end="2"/>
-                                            </p:txEl>
-                                          </p:spTgt>
-                                        </p:tgtEl>
-                                        <p:attrNameLst>
-                                          <p:attrName>style.visibility</p:attrName>
-                                        </p:attrNameLst>
-                                      </p:cBhvr>
-                                      <p:to>
-                                        <p:strVal val="visible"/>
-                                      </p:to>
-                                    </p:set>
-                                  </p:childTnLst>
-                                </p:cTn>
-                              </p:par>
-                            </p:childTnLst>
-                          </p:cTn>
-                        </p:par>
-                      </p:childTnLst>
-                    </p:cTn>
-                  </p:par>
-                </p:childTnLst>
-              </p:cTn>
-              <p:prevCondLst>
-                <p:cond evt="onPrev" delay="0">
-                  <p:tgtEl>
-                    <p:sldTgt/>
-                  </p:tgtEl>
-                </p:cond>
-              </p:prevCondLst>
-              <p:nextCondLst>
-                <p:cond evt="onNext" delay="0">
-                  <p:tgtEl>
-                    <p:sldTgt/>
-                  </p:tgtEl>
-                </p:cond>
-              </p:nextCondLst>
-            </p:seq>
-          </p:childTnLst>
-        </p:cTn>
-      </p:par>
-    </p:tnLst>
-    <p:bldLst>
-      <p:bldP spid="2" grpId="0" uiExpand="1" build="p"/>
-    </p:bldLst>
-  </p:timing>
-</p:sld>
-</file>
-
-<file path=ppt/slides/slide6.xml><?xml version="1.0" encoding="utf-8"?>
-<p:sld xmlns:a="http://schemas.openxmlformats.org/drawingml/2006/main" xmlns:r="http://schemas.openxmlformats.org/officeDocument/2006/relationships" xmlns:p="http://schemas.openxmlformats.org/presentationml/2006/main">
-  <p:cSld>
-    <p:spTree>
-      <p:nvGrpSpPr>
-        <p:cNvPr id="1" name="">
-          <a:extLst>
-            <a:ext uri="{FF2B5EF4-FFF2-40B4-BE49-F238E27FC236}">
-              <a16:creationId xmlns:a16="http://schemas.microsoft.com/office/drawing/2014/main" id="{B5253C69-472F-A80F-ECBC-553E043DB9CF}"/>
-            </a:ext>
-          </a:extLst>
-        </p:cNvPr>
-        <p:cNvGrpSpPr/>
-        <p:nvPr/>
-      </p:nvGrpSpPr>
-      <p:grpSpPr>
-        <a:xfrm>
-          <a:off x="0" y="0"/>
-          <a:ext cx="0" cy="0"/>
-          <a:chOff x="0" y="0"/>
-          <a:chExt cx="0" cy="0"/>
-        </a:xfrm>
-      </p:grpSpPr>
-      <p:sp>
-        <p:nvSpPr>
-          <p:cNvPr id="2" name="Text Placeholder 1">
-            <a:extLst>
-              <a:ext uri="{FF2B5EF4-FFF2-40B4-BE49-F238E27FC236}">
-                <a16:creationId xmlns:a16="http://schemas.microsoft.com/office/drawing/2014/main" id="{A364AF3A-1BAA-BB19-865F-8604C4E3B859}"/>
-              </a:ext>
-            </a:extLst>
-          </p:cNvPr>
-          <p:cNvSpPr>
-            <a:spLocks noGrp="1"/>
-          </p:cNvSpPr>
-          <p:nvPr>
-            <p:ph type="body" sz="quarter" idx="13"/>
-          </p:nvPr>
-        </p:nvSpPr>
-        <p:spPr>
-          <a:xfrm>
-            <a:off x="255996" y="1271219"/>
-            <a:ext cx="10624338" cy="4142989"/>
-          </a:xfrm>
-        </p:spPr>
-        <p:txBody>
-          <a:bodyPr/>
-          <a:lstStyle/>
-          <a:p>
-            <a:pPr marL="0" indent="0">
-              <a:lnSpc>
-                <a:spcPct val="100000"/>
-              </a:lnSpc>
-              <a:buNone/>
-            </a:pPr>
-            <a:r>
-              <a:rPr lang="en-US" b="0" dirty="0">
-                <a:solidFill>
-                  <a:srgbClr val="5583D1"/>
-                </a:solidFill>
-                <a:latin typeface="+mn-lt"/>
-              </a:rPr>
-              <a:t>Current architectural software lacks intelligent, context-aware automation. While standalone LLMs are prone to hallucination, combining them with a Retrieval-Augmented Generation (RAG) pipeline and a robust multi-agent framework ensures grounded, accurate responses based on strict building codes. Furthermore, integrating local execution models (Ollama) addresses critical data privacy concerns inherent in proprietary architectural designs.</a:t>
-            </a:r>
-            <a:endParaRPr lang="en-US" b="0" dirty="0">
-              <a:solidFill>
-                <a:srgbClr val="5583D1"/>
-              </a:solidFill>
-            </a:endParaRPr>
-          </a:p>
-        </p:txBody>
-      </p:sp>
-      <p:sp>
-        <p:nvSpPr>
-          <p:cNvPr id="3" name="TextBox 2">
-            <a:extLst>
-              <a:ext uri="{FF2B5EF4-FFF2-40B4-BE49-F238E27FC236}">
-                <a16:creationId xmlns:a16="http://schemas.microsoft.com/office/drawing/2014/main" id="{C7C2521A-B8A4-7818-FEB4-0309182DBECF}"/>
-              </a:ext>
-            </a:extLst>
-          </p:cNvPr>
-          <p:cNvSpPr txBox="1"/>
-          <p:nvPr/>
-        </p:nvSpPr>
-        <p:spPr>
-          <a:xfrm>
-            <a:off x="255996" y="502545"/>
-            <a:ext cx="10624338" cy="646331"/>
-          </a:xfrm>
-          <a:prstGeom prst="rect">
-            <a:avLst/>
-          </a:prstGeom>
-          <a:noFill/>
-        </p:spPr>
-        <p:txBody>
-          <a:bodyPr wrap="square" rtlCol="0">
-            <a:spAutoFit/>
-          </a:bodyPr>
-          <a:lstStyle/>
-          <a:p>
-            <a:pPr marL="0" marR="0" lvl="0" indent="0" algn="l" defTabSz="914400" rtl="0" eaLnBrk="1" fontAlgn="auto" latinLnBrk="0" hangingPunct="1">
-              <a:lnSpc>
-                <a:spcPct val="100000"/>
-              </a:lnSpc>
-              <a:spcBef>
-                <a:spcPts val="0"/>
-              </a:spcBef>
-              <a:spcAft>
-                <a:spcPts val="0"/>
-              </a:spcAft>
-              <a:buClrTx/>
-              <a:buSzTx/>
-              <a:buFontTx/>
-              <a:buNone/>
-              <a:tabLst/>
-              <a:defRPr/>
-            </a:pPr>
-            <a:r>
-              <a:rPr kumimoji="0" lang="en-US" sz="3600" b="1" i="0" u="none" strike="noStrike" kern="1200" cap="none" spc="0" normalizeH="0" baseline="0" noProof="0" dirty="0">
-                <a:ln>
-                  <a:noFill/>
-                </a:ln>
-                <a:solidFill>
-                  <a:srgbClr val="5B9BD5">
-                    <a:lumMod val="50000"/>
-                  </a:srgbClr>
-                </a:solidFill>
-                <a:effectLst/>
-                <a:uLnTx/>
-                <a:uFillTx/>
-                <a:latin typeface="Calibri" panose="020F0502020204030204"/>
-                <a:ea typeface="+mn-ea"/>
-                <a:cs typeface="+mn-cs"/>
-              </a:rPr>
-              <a:t>Summary of Literature</a:t>
-            </a:r>
-          </a:p>
-        </p:txBody>
-      </p:sp>
-      <p:cxnSp>
-        <p:nvCxnSpPr>
-          <p:cNvPr id="5" name="Straight Connector 4">
-            <a:extLst>
-              <a:ext uri="{FF2B5EF4-FFF2-40B4-BE49-F238E27FC236}">
-                <a16:creationId xmlns:a16="http://schemas.microsoft.com/office/drawing/2014/main" id="{76871527-EAED-D60A-DB4D-12A2CE4201DE}"/>
-              </a:ext>
-            </a:extLst>
-          </p:cNvPr>
-          <p:cNvCxnSpPr>
-            <a:cxnSpLocks/>
-          </p:cNvCxnSpPr>
-          <p:nvPr/>
-        </p:nvCxnSpPr>
-        <p:spPr>
-          <a:xfrm>
-            <a:off x="221274" y="1191756"/>
-            <a:ext cx="7305799" cy="0"/>
-          </a:xfrm>
-          <a:prstGeom prst="line">
-            <a:avLst/>
-          </a:prstGeom>
-          <a:ln w="28575">
-            <a:solidFill>
-              <a:schemeClr val="accent6"/>
-            </a:solidFill>
-          </a:ln>
-        </p:spPr>
-        <p:style>
-          <a:lnRef idx="1">
-            <a:schemeClr val="accent1"/>
-          </a:lnRef>
-          <a:fillRef idx="0">
-            <a:schemeClr val="accent1"/>
-          </a:fillRef>
-          <a:effectRef idx="0">
-            <a:schemeClr val="accent1"/>
-          </a:effectRef>
-          <a:fontRef idx="minor">
-            <a:schemeClr val="tx1"/>
-          </a:fontRef>
-        </p:style>
-      </p:cxnSp>
-      <p:sp>
-        <p:nvSpPr>
-          <p:cNvPr id="4" name="TextBox 3">
-            <a:extLst>
-              <a:ext uri="{FF2B5EF4-FFF2-40B4-BE49-F238E27FC236}">
-                <a16:creationId xmlns:a16="http://schemas.microsoft.com/office/drawing/2014/main" id="{8EADF6DB-6CFE-DDC5-997C-E84EE1A9470D}"/>
-              </a:ext>
-            </a:extLst>
-          </p:cNvPr>
-          <p:cNvSpPr txBox="1"/>
-          <p:nvPr/>
-        </p:nvSpPr>
-        <p:spPr>
-          <a:xfrm>
-            <a:off x="6093893" y="57036"/>
-            <a:ext cx="6098107" cy="646331"/>
-          </a:xfrm>
-          <a:prstGeom prst="rect">
-            <a:avLst/>
-          </a:prstGeom>
-          <a:noFill/>
-        </p:spPr>
-        <p:txBody>
-          <a:bodyPr wrap="square" rtlCol="0">
-            <a:spAutoFit/>
-          </a:bodyPr>
-          <a:lstStyle/>
-          <a:p>
-            <a:pPr algn="r"/>
-            <a:r>
-              <a:rPr lang="en-GB" b="1" i="1" dirty="0">
-                <a:solidFill>
-                  <a:srgbClr val="FFFFFF"/>
-                </a:solidFill>
-              </a:rPr>
-              <a:t>Agentic AI Assistant for Architectural Design and Project Coordination</a:t>
-            </a:r>
-            <a:endParaRPr lang="en-US" dirty="0"/>
-          </a:p>
-        </p:txBody>
-      </p:sp>
-    </p:spTree>
-    <p:extLst>
-      <p:ext uri="{BB962C8B-B14F-4D97-AF65-F5344CB8AC3E}">
-        <p14:creationId xmlns:p14="http://schemas.microsoft.com/office/powerpoint/2010/main" val="4084703370"/>
-      </p:ext>
-    </p:extLst>
-  </p:cSld>
-  <p:clrMapOvr>
-    <a:masterClrMapping/>
-  </p:clrMapOvr>
-  <mc:AlternateContent xmlns:mc="http://schemas.openxmlformats.org/markup-compatibility/2006" xmlns:p14="http://schemas.microsoft.com/office/powerpoint/2010/main">
-    <mc:Choice Requires="p14">
-      <p:transition spd="med" p14:dur="700">
-        <p:fade/>
-      </p:transition>
-    </mc:Choice>
-    <mc:Fallback xmlns="">
-      <p:transition spd="med">
-        <p:fade/>
-      </p:transition>
-    </mc:Fallback>
-  </mc:AlternateContent>
-  <p:timing>
-    <p:tnLst>
-      <p:par>
-        <p:cTn id="1" dur="indefinite" restart="never" nodeType="tmRoot">
-          <p:childTnLst>
-            <p:seq concurrent="1" nextAc="seek">
-              <p:cTn id="2" dur="indefinite" nodeType="mainSeq">
-                <p:childTnLst>
-                  <p:par>
-                    <p:cTn id="3" fill="hold">
-                      <p:stCondLst>
-                        <p:cond delay="indefinite"/>
-                      </p:stCondLst>
-                      <p:childTnLst>
-                        <p:par>
-                          <p:cTn id="4" fill="hold">
-                            <p:stCondLst>
-                              <p:cond delay="0"/>
-                            </p:stCondLst>
-                            <p:childTnLst>
-                              <p:par>
-                                <p:cTn id="5" presetID="1" presetClass="entr" presetSubtype="0" fill="hold" grpId="0" nodeType="clickEffect">
-                                  <p:stCondLst>
-                                    <p:cond delay="0"/>
-                                  </p:stCondLst>
-                                  <p:childTnLst>
-                                    <p:set>
-                                      <p:cBhvr>
-                                        <p:cTn id="6" dur="1" fill="hold">
-                                          <p:stCondLst>
-                                            <p:cond delay="0"/>
-                                          </p:stCondLst>
-                                        </p:cTn>
-                                        <p:tgtEl>
-                                          <p:spTgt spid="2">
-                                            <p:txEl>
-                                              <p:pRg st="0" end="0"/>
                                             </p:txEl>
                                           </p:spTgt>
                                         </p:tgtEl>
@@ -7315,7 +7452,7 @@
         <p:spPr>
           <a:xfrm>
             <a:off x="255996" y="1271219"/>
-            <a:ext cx="10624338" cy="4142989"/>
+            <a:ext cx="11247746" cy="4142989"/>
           </a:xfrm>
         </p:spPr>
         <p:txBody>
@@ -7345,8 +7482,67 @@
                 </a:solidFill>
                 <a:latin typeface="Calibri (Body)"/>
               </a:rPr>
-              <a:t> Project Setup &amp; Knowledge Base Ingestion </a:t>
-            </a:r>
+              <a:t> Project Setup, Infrastructure &amp; Knowledge Base</a:t>
+            </a:r>
+          </a:p>
+          <a:p>
+            <a:pPr marL="457200" lvl="1" indent="0">
+              <a:lnSpc>
+                <a:spcPct val="100000"/>
+              </a:lnSpc>
+              <a:buNone/>
+            </a:pPr>
+            <a:r>
+              <a:rPr lang="en-GB" sz="2000" b="0" dirty="0">
+                <a:solidFill>
+                  <a:srgbClr val="5583D1"/>
+                </a:solidFill>
+                <a:latin typeface="Calibri (Body)"/>
+              </a:rPr>
+              <a:t>Containerized deployment of the web application, databases (PostgreSQL/</a:t>
+            </a:r>
+            <a:r>
+              <a:rPr lang="en-GB" sz="2000" b="0" dirty="0" err="1">
+                <a:solidFill>
+                  <a:srgbClr val="5583D1"/>
+                </a:solidFill>
+                <a:latin typeface="Calibri (Body)"/>
+              </a:rPr>
+              <a:t>MinIO</a:t>
+            </a:r>
+            <a:r>
+              <a:rPr lang="en-GB" sz="2000" b="0" dirty="0">
+                <a:solidFill>
+                  <a:srgbClr val="5583D1"/>
+                </a:solidFill>
+                <a:latin typeface="Calibri (Body)"/>
+              </a:rPr>
+              <a:t>), and vector store (</a:t>
+            </a:r>
+            <a:r>
+              <a:rPr lang="en-GB" sz="2000" b="0" dirty="0" err="1">
+                <a:solidFill>
+                  <a:srgbClr val="5583D1"/>
+                </a:solidFill>
+                <a:latin typeface="Calibri (Body)"/>
+              </a:rPr>
+              <a:t>ChromaDB</a:t>
+            </a:r>
+            <a:r>
+              <a:rPr lang="en-GB" sz="2000" b="0" dirty="0">
+                <a:solidFill>
+                  <a:srgbClr val="5583D1"/>
+                </a:solidFill>
+                <a:latin typeface="Calibri (Body)"/>
+              </a:rPr>
+              <a:t>) to handle document ingestion and project definition.</a:t>
+            </a:r>
+            <a:endParaRPr lang="en-US" sz="1800" b="0" dirty="0">
+              <a:solidFill>
+                <a:srgbClr val="5583D1"/>
+              </a:solidFill>
+              <a:latin typeface="Calibri (Body)"/>
+            </a:endParaRPr>
           </a:p>
           <a:p>
             <a:pPr marL="514350" indent="-514350">
@@ -7372,7 +7568,33 @@
                 </a:solidFill>
                 <a:latin typeface="Calibri (Body)"/>
               </a:rPr>
-              <a:t> Multi-Agent Orchestration Engine (LangGraph) </a:t>
+              <a:t> Multi-Agent Orchestration Engine (LangGraph)</a:t>
+            </a:r>
+          </a:p>
+          <a:p>
+            <a:pPr marL="457200" lvl="1" indent="0">
+              <a:lnSpc>
+                <a:spcPct val="100000"/>
+              </a:lnSpc>
+              <a:buNone/>
+            </a:pPr>
+            <a:r>
+              <a:rPr lang="en-GB" dirty="0">
+                <a:solidFill>
+                  <a:srgbClr val="5583D1"/>
+                </a:solidFill>
+                <a:latin typeface="Calibri (Body)"/>
+              </a:rPr>
+              <a:t>A state-machine framework coordinating specialized local LLM agents to reliably execute complex architectural tasks and semantic searches.</a:t>
+            </a:r>
+            <a:r>
+              <a:rPr lang="en-US" b="0" dirty="0">
+                <a:solidFill>
+                  <a:srgbClr val="5583D1"/>
+                </a:solidFill>
+                <a:latin typeface="Calibri (Body)"/>
+              </a:rPr>
+              <a:t> </a:t>
             </a:r>
           </a:p>
           <a:p>
@@ -7403,6 +7625,26 @@
             </a:r>
           </a:p>
           <a:p>
+            <a:pPr marL="457200" lvl="1" indent="0">
+              <a:buNone/>
+            </a:pPr>
+            <a:r>
+              <a:rPr lang="en-GB" dirty="0">
+                <a:solidFill>
+                  <a:srgbClr val="5583D1"/>
+                </a:solidFill>
+                <a:latin typeface="Calibri (Body)"/>
+              </a:rPr>
+              <a:t>Automated compliance auditing of floor plan datasets against building codes, providing structured citations, visual feedback, and reports.</a:t>
+            </a:r>
+            <a:endParaRPr lang="en-US" b="0" dirty="0">
+              <a:solidFill>
+                <a:srgbClr val="5583D1"/>
+              </a:solidFill>
+              <a:latin typeface="Calibri (Body)"/>
+            </a:endParaRPr>
+          </a:p>
+          <a:p>
             <a:pPr marL="514350" indent="-514350">
               <a:lnSpc>
                 <a:spcPct val="100000"/>
@@ -7426,8 +7668,46 @@
                 </a:solidFill>
                 <a:latin typeface="Calibri (Body)"/>
               </a:rPr>
-              <a:t> Agent Evaluation &amp; Performance Tracking</a:t>
-            </a:r>
+              <a:t> Agent Evaluation, Tracking &amp; CI/CD</a:t>
+            </a:r>
+          </a:p>
+          <a:p>
+            <a:pPr marL="457200" lvl="1" indent="0">
+              <a:buNone/>
+            </a:pPr>
+            <a:r>
+              <a:rPr lang="en-GB" dirty="0">
+                <a:solidFill>
+                  <a:srgbClr val="5583D1"/>
+                </a:solidFill>
+                <a:latin typeface="Calibri (Body)"/>
+              </a:rPr>
+              <a:t>Implementation of </a:t>
+            </a:r>
+            <a:r>
+              <a:rPr lang="en-GB" dirty="0" err="1">
+                <a:solidFill>
+                  <a:srgbClr val="5583D1"/>
+                </a:solidFill>
+                <a:latin typeface="Calibri (Body)"/>
+              </a:rPr>
+              <a:t>MLflow</a:t>
+            </a:r>
+            <a:r>
+              <a:rPr lang="en-GB" dirty="0">
+                <a:solidFill>
+                  <a:srgbClr val="5583D1"/>
+                </a:solidFill>
+                <a:latin typeface="Calibri (Body)"/>
+              </a:rPr>
+              <a:t> for monitoring agent accuracy and system metrics, alongside a GitHub Actions pipeline for continuous integration.</a:t>
+            </a:r>
+            <a:endParaRPr lang="en-US" b="0" dirty="0">
+              <a:solidFill>
+                <a:srgbClr val="5583D1"/>
+              </a:solidFill>
+              <a:latin typeface="Calibri (Body)"/>
+            </a:endParaRPr>
           </a:p>
         </p:txBody>
       </p:sp>
@@ -7655,33 +7935,15 @@
                                   </p:childTnLst>
                                 </p:cTn>
                               </p:par>
-                            </p:childTnLst>
-                          </p:cTn>
-                        </p:par>
-                      </p:childTnLst>
-                    </p:cTn>
-                  </p:par>
-                  <p:par>
-                    <p:cTn id="7" fill="hold">
-                      <p:stCondLst>
-                        <p:cond delay="indefinite"/>
-                      </p:stCondLst>
-                      <p:childTnLst>
-                        <p:par>
-                          <p:cTn id="8" fill="hold">
-                            <p:stCondLst>
-                              <p:cond delay="0"/>
-                            </p:stCondLst>
-                            <p:childTnLst>
                               <p:par>
-                                <p:cTn id="9" presetID="1" presetClass="entr" presetSubtype="0" fill="hold" grpId="0" nodeType="clickEffect">
+                                <p:cTn id="7" presetID="1" presetClass="entr" presetSubtype="0" fill="hold" grpId="0" nodeType="withEffect">
                                   <p:stCondLst>
                                     <p:cond delay="0"/>
                                   </p:stCondLst>
                                   <p:childTnLst>
                                     <p:set>
                                       <p:cBhvr>
-                                        <p:cTn id="10" dur="1" fill="hold">
+                                        <p:cTn id="8" dur="1" fill="hold">
                                           <p:stCondLst>
                                             <p:cond delay="0"/>
                                           </p:stCondLst>
@@ -7711,19 +7973,50 @@
                     </p:cTn>
                   </p:par>
                   <p:par>
-                    <p:cTn id="11" fill="hold">
+                    <p:cTn id="9" fill="hold">
                       <p:stCondLst>
                         <p:cond delay="indefinite"/>
                       </p:stCondLst>
                       <p:childTnLst>
                         <p:par>
-                          <p:cTn id="12" fill="hold">
+                          <p:cTn id="10" fill="hold">
                             <p:stCondLst>
                               <p:cond delay="0"/>
                             </p:stCondLst>
                             <p:childTnLst>
                               <p:par>
-                                <p:cTn id="13" presetID="1" presetClass="entr" presetSubtype="0" fill="hold" grpId="0" nodeType="clickEffect">
+                                <p:cTn id="11" presetID="1" presetClass="entr" presetSubtype="0" fill="hold" grpId="0" nodeType="clickEffect">
+                                  <p:stCondLst>
+                                    <p:cond delay="0"/>
+                                  </p:stCondLst>
+                                  <p:childTnLst>
+                                    <p:set>
+                                      <p:cBhvr>
+                                        <p:cTn id="12" dur="1" fill="hold">
+                                          <p:stCondLst>
+                                            <p:cond delay="0"/>
+                                          </p:stCondLst>
+                                        </p:cTn>
+                                        <p:tgtEl>
+                                          <p:spTgt spid="2">
+                                            <p:txEl>
+                                              <p:pRg st="2" end="2"/>
+                                            </p:txEl>
+                                          </p:spTgt>
+                                        </p:tgtEl>
+                                        <p:attrNameLst>
+                                          <p:attrName>style.visibility</p:attrName>
+                                        </p:attrNameLst>
+                                      </p:cBhvr>
+                                      <p:to>
+                                        <p:strVal val="visible"/>
+                                      </p:to>
+                                    </p:set>
+                                  </p:childTnLst>
+                                </p:cTn>
+                              </p:par>
+                              <p:par>
+                                <p:cTn id="13" presetID="1" presetClass="entr" presetSubtype="0" fill="hold" grpId="0" nodeType="withEffect">
                                   <p:stCondLst>
                                     <p:cond delay="0"/>
                                   </p:stCondLst>
@@ -7738,7 +8031,7 @@
                                         <p:tgtEl>
                                           <p:spTgt spid="2">
                                             <p:txEl>
-                                              <p:pRg st="2" end="2"/>
+                                              <p:pRg st="3" end="3"/>
                                             </p:txEl>
                                           </p:spTgt>
                                         </p:tgtEl>
@@ -7787,7 +8080,118 @@
                                         <p:tgtEl>
                                           <p:spTgt spid="2">
                                             <p:txEl>
-                                              <p:pRg st="3" end="3"/>
+                                              <p:pRg st="4" end="4"/>
+                                            </p:txEl>
+                                          </p:spTgt>
+                                        </p:tgtEl>
+                                        <p:attrNameLst>
+                                          <p:attrName>style.visibility</p:attrName>
+                                        </p:attrNameLst>
+                                      </p:cBhvr>
+                                      <p:to>
+                                        <p:strVal val="visible"/>
+                                      </p:to>
+                                    </p:set>
+                                  </p:childTnLst>
+                                </p:cTn>
+                              </p:par>
+                              <p:par>
+                                <p:cTn id="19" presetID="1" presetClass="entr" presetSubtype="0" fill="hold" grpId="0" nodeType="withEffect">
+                                  <p:stCondLst>
+                                    <p:cond delay="0"/>
+                                  </p:stCondLst>
+                                  <p:childTnLst>
+                                    <p:set>
+                                      <p:cBhvr>
+                                        <p:cTn id="20" dur="1" fill="hold">
+                                          <p:stCondLst>
+                                            <p:cond delay="0"/>
+                                          </p:stCondLst>
+                                        </p:cTn>
+                                        <p:tgtEl>
+                                          <p:spTgt spid="2">
+                                            <p:txEl>
+                                              <p:pRg st="5" end="5"/>
+                                            </p:txEl>
+                                          </p:spTgt>
+                                        </p:tgtEl>
+                                        <p:attrNameLst>
+                                          <p:attrName>style.visibility</p:attrName>
+                                        </p:attrNameLst>
+                                      </p:cBhvr>
+                                      <p:to>
+                                        <p:strVal val="visible"/>
+                                      </p:to>
+                                    </p:set>
+                                  </p:childTnLst>
+                                </p:cTn>
+                              </p:par>
+                            </p:childTnLst>
+                          </p:cTn>
+                        </p:par>
+                      </p:childTnLst>
+                    </p:cTn>
+                  </p:par>
+                  <p:par>
+                    <p:cTn id="21" fill="hold">
+                      <p:stCondLst>
+                        <p:cond delay="indefinite"/>
+                      </p:stCondLst>
+                      <p:childTnLst>
+                        <p:par>
+                          <p:cTn id="22" fill="hold">
+                            <p:stCondLst>
+                              <p:cond delay="0"/>
+                            </p:stCondLst>
+                            <p:childTnLst>
+                              <p:par>
+                                <p:cTn id="23" presetID="1" presetClass="entr" presetSubtype="0" fill="hold" grpId="0" nodeType="clickEffect">
+                                  <p:stCondLst>
+                                    <p:cond delay="0"/>
+                                  </p:stCondLst>
+                                  <p:childTnLst>
+                                    <p:set>
+                                      <p:cBhvr>
+                                        <p:cTn id="24" dur="1" fill="hold">
+                                          <p:stCondLst>
+                                            <p:cond delay="0"/>
+                                          </p:stCondLst>
+                                        </p:cTn>
+                                        <p:tgtEl>
+                                          <p:spTgt spid="2">
+                                            <p:txEl>
+                                              <p:pRg st="6" end="6"/>
+                                            </p:txEl>
+                                          </p:spTgt>
+                                        </p:tgtEl>
+                                        <p:attrNameLst>
+                                          <p:attrName>style.visibility</p:attrName>
+                                        </p:attrNameLst>
+                                      </p:cBhvr>
+                                      <p:to>
+                                        <p:strVal val="visible"/>
+                                      </p:to>
+                                    </p:set>
+                                  </p:childTnLst>
+                                </p:cTn>
+                              </p:par>
+                              <p:par>
+                                <p:cTn id="25" presetID="1" presetClass="entr" presetSubtype="0" fill="hold" grpId="0" nodeType="withEffect">
+                                  <p:stCondLst>
+                                    <p:cond delay="0"/>
+                                  </p:stCondLst>
+                                  <p:childTnLst>
+                                    <p:set>
+                                      <p:cBhvr>
+                                        <p:cTn id="26" dur="1" fill="hold">
+                                          <p:stCondLst>
+                                            <p:cond delay="0"/>
+                                          </p:stCondLst>
+                                        </p:cTn>
+                                        <p:tgtEl>
+                                          <p:spTgt spid="2">
+                                            <p:txEl>
+                                              <p:pRg st="7" end="7"/>
                                             </p:txEl>
                                           </p:spTgt>
                                         </p:tgtEl>
@@ -7884,43 +8288,98 @@
                 </a:solidFill>
                 <a:latin typeface="+mn-lt"/>
               </a:rPr>
-              <a:t>Subtopic - UI Development &amp; Data Pipeline</a:t>
-            </a:r>
+              <a:t>Subtopic - </a:t>
+            </a:r>
+            <a:r>
+              <a:rPr lang="en-GB" dirty="0">
+                <a:solidFill>
+                  <a:srgbClr val="5583D1"/>
+                </a:solidFill>
+                <a:latin typeface="+mn-lt"/>
+              </a:rPr>
+              <a:t>UI Development &amp; Containerized Data Pipeline</a:t>
+            </a:r>
+            <a:endParaRPr lang="en-US" dirty="0">
+              <a:solidFill>
+                <a:srgbClr val="5583D1"/>
+              </a:solidFill>
+              <a:latin typeface="+mn-lt"/>
+            </a:endParaRPr>
           </a:p>
           <a:p>
             <a:pPr lvl="1"/>
-            <a:r>
-              <a:rPr lang="en-GB" dirty="0">
+            <a:endParaRPr lang="en-GB" dirty="0">
+              <a:solidFill>
+                <a:srgbClr val="1C3898"/>
+              </a:solidFill>
+            </a:endParaRPr>
+          </a:p>
+          <a:p>
+            <a:pPr lvl="1"/>
+            <a:r>
+              <a:rPr lang="en-GB" sz="2800" dirty="0">
                 <a:solidFill>
                   <a:srgbClr val="1C3898"/>
                 </a:solidFill>
               </a:rPr>
-              <a:t>Development of a Streamlit frontend for project creation, constraint definition, and chat interaction. </a:t>
+              <a:t>Frontend &amp; UX: Development of a Streamlit frontend for project creation, constraint definition, and chat interaction. </a:t>
             </a:r>
           </a:p>
           <a:p>
             <a:pPr lvl="1"/>
             <a:r>
-              <a:rPr lang="en-GB" dirty="0">
+              <a:rPr lang="en-GB" sz="2800" dirty="0">
                 <a:solidFill>
                   <a:srgbClr val="1C3898"/>
                 </a:solidFill>
               </a:rPr>
-              <a:t>Implementation of a document upload pipeline for architectural drawings (IFC) and regulatory texts (PDF, DOCX). </a:t>
+              <a:t>Containerized Infrastructure: Orchestration of the application stack (</a:t>
+            </a:r>
+            <a:r>
+              <a:rPr lang="en-GB" sz="2800" dirty="0" err="1">
+                <a:solidFill>
+                  <a:srgbClr val="1C3898"/>
+                </a:solidFill>
+              </a:rPr>
+              <a:t>FastAPI</a:t>
+            </a:r>
+            <a:r>
+              <a:rPr lang="en-GB" sz="2800" dirty="0">
+                <a:solidFill>
+                  <a:srgbClr val="1C3898"/>
+                </a:solidFill>
+              </a:rPr>
+              <a:t>, Streamlit, PostgreSQL, </a:t>
+            </a:r>
+            <a:r>
+              <a:rPr lang="en-GB" sz="2800" dirty="0" err="1">
+                <a:solidFill>
+                  <a:srgbClr val="1C3898"/>
+                </a:solidFill>
+              </a:rPr>
+              <a:t>MinIO</a:t>
+            </a:r>
+            <a:r>
+              <a:rPr lang="en-GB" sz="2800" dirty="0">
+                <a:solidFill>
+                  <a:srgbClr val="1C3898"/>
+                </a:solidFill>
+              </a:rPr>
+              <a:t>) using Docker Compose for reproducible deployment. </a:t>
             </a:r>
           </a:p>
           <a:p>
             <a:pPr lvl="1"/>
             <a:r>
-              <a:rPr lang="en-GB" dirty="0">
+              <a:rPr lang="en-GB" sz="2800" dirty="0">
                 <a:solidFill>
                   <a:srgbClr val="1C3898"/>
                 </a:solidFill>
               </a:rPr>
-              <a:t>Automated parsing, chunking, and indexing of building codes into a </a:t>
-            </a:r>
-            <a:r>
-              <a:rPr lang="en-GB" dirty="0" err="1">
+              <a:t>Knowledge Base Ingestion: Automated parsing, chunking, and indexing of building codes into a </a:t>
+            </a:r>
+            <a:r>
+              <a:rPr lang="en-GB" sz="2800" dirty="0" err="1">
                 <a:solidFill>
                   <a:srgbClr val="1C3898"/>
                 </a:solidFill>
@@ -7928,14 +8387,14 @@
               <a:t>ChromaDB</a:t>
             </a:r>
             <a:r>
-              <a:rPr lang="en-GB" dirty="0">
+              <a:rPr lang="en-GB" sz="2800" dirty="0">
                 <a:solidFill>
                   <a:srgbClr val="1C3898"/>
                 </a:solidFill>
               </a:rPr>
               <a:t> vector store.</a:t>
             </a:r>
-            <a:endParaRPr lang="en-US" dirty="0">
+            <a:endParaRPr lang="en-US" sz="2800" dirty="0">
               <a:solidFill>
                 <a:srgbClr val="1C3898"/>
               </a:solidFill>
@@ -8205,99 +8664,6 @@
                                           <p:spTgt spid="2">
                                             <p:txEl>
                                               <p:pRg st="0" end="0"/>
-                                            </p:txEl>
-                                          </p:spTgt>
-                                        </p:tgtEl>
-                                        <p:attrNameLst>
-                                          <p:attrName>style.visibility</p:attrName>
-                                        </p:attrNameLst>
-                                      </p:cBhvr>
-                                      <p:to>
-                                        <p:strVal val="visible"/>
-                                      </p:to>
-                                    </p:set>
-                                  </p:childTnLst>
-                                </p:cTn>
-                              </p:par>
-                              <p:par>
-                                <p:cTn id="11" presetID="1" presetClass="entr" presetSubtype="0" fill="hold" grpId="0" nodeType="withEffect">
-                                  <p:stCondLst>
-                                    <p:cond delay="0"/>
-                                  </p:stCondLst>
-                                  <p:childTnLst>
-                                    <p:set>
-                                      <p:cBhvr>
-                                        <p:cTn id="12" dur="1" fill="hold">
-                                          <p:stCondLst>
-                                            <p:cond delay="0"/>
-                                          </p:stCondLst>
-                                        </p:cTn>
-                                        <p:tgtEl>
-                                          <p:spTgt spid="2">
-                                            <p:txEl>
-                                              <p:pRg st="1" end="1"/>
-                                            </p:txEl>
-                                          </p:spTgt>
-                                        </p:tgtEl>
-                                        <p:attrNameLst>
-                                          <p:attrName>style.visibility</p:attrName>
-                                        </p:attrNameLst>
-                                      </p:cBhvr>
-                                      <p:to>
-                                        <p:strVal val="visible"/>
-                                      </p:to>
-                                    </p:set>
-                                  </p:childTnLst>
-                                </p:cTn>
-                              </p:par>
-                              <p:par>
-                                <p:cTn id="13" presetID="1" presetClass="entr" presetSubtype="0" fill="hold" grpId="0" nodeType="withEffect">
-                                  <p:stCondLst>
-                                    <p:cond delay="0"/>
-                                  </p:stCondLst>
-                                  <p:childTnLst>
-                                    <p:set>
-                                      <p:cBhvr>
-                                        <p:cTn id="14" dur="1" fill="hold">
-                                          <p:stCondLst>
-                                            <p:cond delay="0"/>
-                                          </p:stCondLst>
-                                        </p:cTn>
-                                        <p:tgtEl>
-                                          <p:spTgt spid="2">
-                                            <p:txEl>
-                                              <p:pRg st="2" end="2"/>
-                                            </p:txEl>
-                                          </p:spTgt>
-                                        </p:tgtEl>
-                                        <p:attrNameLst>
-                                          <p:attrName>style.visibility</p:attrName>
-                                        </p:attrNameLst>
-                                      </p:cBhvr>
-                                      <p:to>
-                                        <p:strVal val="visible"/>
-                                      </p:to>
-                                    </p:set>
-                                  </p:childTnLst>
-                                </p:cTn>
-                              </p:par>
-                              <p:par>
-                                <p:cTn id="15" presetID="1" presetClass="entr" presetSubtype="0" fill="hold" grpId="0" nodeType="withEffect">
-                                  <p:stCondLst>
-                                    <p:cond delay="0"/>
-                                  </p:stCondLst>
-                                  <p:childTnLst>
-                                    <p:set>
-                                      <p:cBhvr>
-                                        <p:cTn id="16" dur="1" fill="hold">
-                                          <p:stCondLst>
-                                            <p:cond delay="0"/>
-                                          </p:stCondLst>
-                                        </p:cTn>
-                                        <p:tgtEl>
-                                          <p:spTgt spid="2">
-                                            <p:txEl>
-                                              <p:pRg st="3" end="3"/>
                                             </p:txEl>
                                           </p:spTgt>
                                         </p:tgtEl>

</xml_diff>